<commit_message>
adiciona slides da apresentação sobre alocação de VMs e otimização bioobjetivo
</commit_message>
<xml_diff>
--- a/slides/slides.pptx
+++ b/slides/slides.pptx
@@ -17,9 +17,10 @@
     <p:sldId id="265" r:id="rId11"/>
     <p:sldId id="266" r:id="rId12"/>
     <p:sldId id="267" r:id="rId13"/>
+    <p:sldId id="268" r:id="rId14"/>
   </p:sldIdLst>
   <p:notesMasterIdLst>
-    <p:notesMasterId r:id="rId14"/>
+    <p:notesMasterId r:id="rId15"/>
   </p:notesMasterIdLst>
   <p:sldSz cx="9144000" cy="5143500"/>
   <p:notesSz cx="5143500" cy="9144000"/>
@@ -513,7 +514,7 @@
           <a:p>
             <a:r>
               <a:rPr lang="en-US" dirty="0"/>
-              <a:t>Apresentar o tema: alocação de VMs em data centers, otimizando energia e desperdício ao mesmo tempo, com um algoritmo de colônia de formigas (VMPACS), baseado em Gao et al. (2013).</a:t>
+              <a:t>Apresentar o tema: alocação de VMs em data centers, otimizando energia e desperdício ao mesmo tempo, com colônia de formigas (VMPACS), baseado em Gao et al. (2013).</a:t>
             </a:r>
             <a:endParaRPr lang="en-US" dirty="0"/>
           </a:p>
@@ -601,7 +602,7 @@
           <a:p>
             <a:r>
               <a:rPr lang="en-US" dirty="0"/>
-              <a:t>A curva cinza e a fronteira REAL (melhor conhecida): existe um trade-off, porem raso. Os algoritmos convergem para o joelho de menor energia; o NSGA-II encosta na fronteira e o VMPACS fica um pouco acima (minimiza servidores, equilibra menos).</a:t>
+              <a:t>A curva cinza e a fronteira REAL (melhor conhecida): trade-off existe, porem raso. Os algoritmos convergem para o joelho de menor energia; o NSGA-II encosta na fronteira e o VMPACS fica um pouco acima.</a:t>
             </a:r>
             <a:endParaRPr lang="en-US" dirty="0"/>
           </a:p>
@@ -689,7 +690,7 @@
           <a:p>
             <a:r>
               <a:rPr lang="en-US" dirty="0"/>
-              <a:t>Pontos principais: NSGA-II converge melhor; VMPACS mais diverso em correlação negativa; objetivos quase alinhados -&gt; fronteira compacta; efeito da correlação.</a:t>
+              <a:t>Pontos principais: NSGA-II converge melhor; VMPACS mais diverso em correlação negativa; objetivos quase alinhados; efeito da correlação.</a:t>
             </a:r>
             <a:endParaRPr lang="en-US" dirty="0"/>
           </a:p>
@@ -777,7 +778,7 @@
           <a:p>
             <a:r>
               <a:rPr lang="en-US" dirty="0"/>
-              <a:t>Fechar com os três aprendizados e os trabalhos futuros. Agradecer e abrir para perguntas.</a:t>
+              <a:t>Fechar com os três aprendizados e os trabalhos futuros.</a:t>
             </a:r>
             <a:endParaRPr lang="en-US" dirty="0"/>
           </a:p>
@@ -801,6 +802,94 @@
             <a:fld id="{F7021451-1387-4CA6-816F-3879F97B5CBC}" type="slidenum">
               <a:rPr lang="en-US"/>
               <a:t>12</a:t>
+            </a:fld>
+            <a:endParaRPr lang="en-US"/>
+          </a:p>
+        </p:txBody>
+      </p:sp>
+    </p:spTree>
+    <p:extLst>
+      <p:ext uri="{BB962C8B-B14F-4D97-AF65-F5344CB8AC3E}">
+        <p14:creationId xmlns:p14="http://schemas.microsoft.com/office/powerpoint/2010/main" val="1024086991"/>
+      </p:ext>
+    </p:extLst>
+  </p:cSld>
+  <p:clrMapOvr>
+    <a:masterClrMapping/>
+  </p:clrMapOvr>
+</p:notes>
+</file>
+
+<file path=ppt/notesSlides/notesSlide13.xml><?xml version="1.0" encoding="utf-8"?>
+<p:notes xmlns:a="http://schemas.openxmlformats.org/drawingml/2006/main" xmlns:r="http://schemas.openxmlformats.org/officeDocument/2006/relationships" xmlns:p="http://schemas.openxmlformats.org/presentationml/2006/main">
+  <p:cSld>
+    <p:spTree>
+      <p:nvGrpSpPr>
+        <p:cNvPr id="1" name=""/>
+        <p:cNvGrpSpPr/>
+        <p:nvPr/>
+      </p:nvGrpSpPr>
+      <p:grpSpPr>
+        <a:xfrm>
+          <a:off x="0" y="0"/>
+          <a:ext cx="0" cy="0"/>
+          <a:chOff x="0" y="0"/>
+          <a:chExt cx="0" cy="0"/>
+        </a:xfrm>
+      </p:grpSpPr>
+      <p:sp>
+        <p:nvSpPr>
+          <p:cNvPr id="2" name="Slide Image Placeholder 1"/>
+          <p:cNvSpPr>
+            <a:spLocks noGrp="1" noRot="1" noChangeAspect="1"/>
+          </p:cNvSpPr>
+          <p:nvPr>
+            <p:ph type="sldImg"/>
+          </p:nvPr>
+        </p:nvSpPr>
+        <p:spPr/>
+      </p:sp>
+      <p:sp>
+        <p:nvSpPr>
+          <p:cNvPr id="3" name="Notes Placeholder 2"/>
+          <p:cNvSpPr>
+            <a:spLocks noGrp="1"/>
+          </p:cNvSpPr>
+          <p:nvPr>
+            <p:ph type="body" idx="1"/>
+          </p:nvPr>
+        </p:nvSpPr>
+        <p:spPr/>
+        <p:txBody>
+          <a:bodyPr/>
+          <a:lstStyle/>
+          <a:p>
+            <a:r>
+              <a:rPr lang="en-US" dirty="0"/>
+              <a:t>Slide de fechamento: agradecer e abrir para perguntas.</a:t>
+            </a:r>
+            <a:endParaRPr lang="en-US" dirty="0"/>
+          </a:p>
+        </p:txBody>
+      </p:sp>
+      <p:sp>
+        <p:nvSpPr>
+          <p:cNvPr id="4" name="Slide Number Placeholder 3"/>
+          <p:cNvSpPr>
+            <a:spLocks noGrp="1"/>
+          </p:cNvSpPr>
+          <p:nvPr>
+            <p:ph type="sldNum" sz="quarter" idx="10"/>
+          </p:nvPr>
+        </p:nvSpPr>
+        <p:spPr/>
+        <p:txBody>
+          <a:bodyPr/>
+          <a:lstStyle/>
+          <a:p>
+            <a:fld id="{F7021451-1387-4CA6-816F-3879F97B5CBC}" type="slidenum">
+              <a:rPr lang="en-US"/>
+              <a:t>13</a:t>
             </a:fld>
             <a:endParaRPr lang="en-US"/>
           </a:p>
@@ -865,7 +954,7 @@
           <a:p>
             <a:r>
               <a:rPr lang="en-US" dirty="0"/>
-              <a:t>Consolidação: em vez de 1 VM por servidor, agrupamos VMs para ligar menos máquinas, sem desbalancear CPU e memória.</a:t>
+              <a:t>Consolidação: agrupar VMs para ligar menos máquinas, sem desbalancear CPU e memória.</a:t>
             </a:r>
             <a:endParaRPr lang="en-US" dirty="0"/>
           </a:p>
@@ -953,7 +1042,7 @@
           <a:p>
             <a:r>
               <a:rPr lang="en-US" dirty="0"/>
-              <a:t>Os dois objetivos competem: a resposta não é uma solução única, e sim um conjunto de soluções não-dominadas (fronteira de Pareto).</a:t>
+              <a:t>Os dois objetivos competem: a resposta é um conjunto de soluções não-dominadas (fronteira de Pareto).</a:t>
             </a:r>
             <a:endParaRPr lang="en-US" dirty="0"/>
           </a:p>
@@ -1041,7 +1130,7 @@
           <a:p>
             <a:r>
               <a:rPr lang="en-US" dirty="0"/>
-              <a:t>f1 = energia (depende do número de servidores ligados). f2 = desperdício (desbalanceamento CPU/memória). Restrições: cada VM em 1 servidor e limites de capacidade.</a:t>
+              <a:t>f1 = energia (nº de servidores ligados). f2 = desperdício (desbalanceamento CPU/memória). Restrições: cada VM em 1 servidor e limites de capacidade.</a:t>
             </a:r>
             <a:endParaRPr lang="en-US" dirty="0"/>
           </a:p>
@@ -1217,7 +1306,7 @@
           <a:p>
             <a:r>
               <a:rPr lang="en-US" dirty="0"/>
-              <a:t>Construção gulosa-probabilística: a formiga enche um servidor de cada vez, escolhendo VMs pela combinação feromônio+heurística, até alocar todas.</a:t>
+              <a:t>Construção gulosa-probabilística: enche um servidor de cada vez, escolhendo VMs por feromônio+heurística, até alocar todas.</a:t>
             </a:r>
             <a:endParaRPr lang="en-US" dirty="0"/>
           </a:p>
@@ -1305,7 +1394,7 @@
           <a:p>
             <a:r>
               <a:rPr lang="en-US" dirty="0"/>
-              <a:t>NSGA-II: ordenação por não-dominância + crowding. Usamos codificação por permutação com decodificador first-fit.</a:t>
+              <a:t>NSGA-II: ordenação por não-dominância + crowding. Codificação por permutação com decodificador first-fit.</a:t>
             </a:r>
             <a:endParaRPr lang="en-US" dirty="0"/>
           </a:p>
@@ -1393,7 +1482,7 @@
           <a:p>
             <a:r>
               <a:rPr lang="en-US" dirty="0"/>
-              <a:t>100 VMs, 5 correlações, orçamentos equiparados em ~1000 avaliações, 4 métricas e 10 execuções.</a:t>
+              <a:t>100 VMs, 5 correlações, orçamentos equiparados em ~1000 avaliações, 4 métricas, 10 execuções.</a:t>
             </a:r>
             <a:endParaRPr lang="en-US" dirty="0"/>
           </a:p>
@@ -2300,6 +2389,45 @@
           </a:p>
         </p:txBody>
       </p:sp>
+      <p:sp>
+        <p:nvSpPr>
+          <p:cNvPr id="18" name="Text 15"/>
+          <p:cNvSpPr/>
+          <p:nvPr/>
+        </p:nvSpPr>
+        <p:spPr>
+          <a:xfrm>
+            <a:off x="8229600" y="4809744"/>
+            <a:ext cx="658368" cy="274320"/>
+          </a:xfrm>
+          <a:prstGeom prst="rect">
+            <a:avLst/>
+          </a:prstGeom>
+          <a:noFill/>
+          <a:ln/>
+        </p:spPr>
+        <p:txBody>
+          <a:bodyPr wrap="square" lIns="0" tIns="0" rIns="0" bIns="0" rtlCol="0" anchor="ctr"/>
+          <a:lstStyle/>
+          <a:p>
+            <a:pPr algn="r" indent="0" marL="0">
+              <a:buNone/>
+            </a:pPr>
+            <a:r>
+              <a:rPr lang="en-US" sz="1100" dirty="0">
+                <a:solidFill>
+                  <a:srgbClr val="7E97A0"/>
+                </a:solidFill>
+                <a:latin typeface="Calibri" pitchFamily="34" charset="0"/>
+                <a:ea typeface="Calibri" pitchFamily="34" charset="-122"/>
+                <a:cs typeface="Calibri" pitchFamily="34" charset="-120"/>
+              </a:rPr>
+              <a:t>1</a:t>
+            </a:r>
+            <a:endParaRPr lang="en-US" sz="1100" dirty="0"/>
+          </a:p>
+        </p:txBody>
+      </p:sp>
     </p:spTree>
   </p:cSld>
   <p:clrMapOvr>
@@ -2652,6 +2780,45 @@
           </a:prstGeom>
         </p:spPr>
       </p:pic>
+      <p:sp>
+        <p:nvSpPr>
+          <p:cNvPr id="12" name="Text 6"/>
+          <p:cNvSpPr/>
+          <p:nvPr/>
+        </p:nvSpPr>
+        <p:spPr>
+          <a:xfrm>
+            <a:off x="8229600" y="4809744"/>
+            <a:ext cx="658368" cy="274320"/>
+          </a:xfrm>
+          <a:prstGeom prst="rect">
+            <a:avLst/>
+          </a:prstGeom>
+          <a:noFill/>
+          <a:ln/>
+        </p:spPr>
+        <p:txBody>
+          <a:bodyPr wrap="square" lIns="0" tIns="0" rIns="0" bIns="0" rtlCol="0" anchor="ctr"/>
+          <a:lstStyle/>
+          <a:p>
+            <a:pPr algn="r" indent="0" marL="0">
+              <a:buNone/>
+            </a:pPr>
+            <a:r>
+              <a:rPr lang="en-US" sz="1100" dirty="0">
+                <a:solidFill>
+                  <a:srgbClr val="9AA5AD"/>
+                </a:solidFill>
+                <a:latin typeface="Calibri" pitchFamily="34" charset="0"/>
+                <a:ea typeface="Calibri" pitchFamily="34" charset="-122"/>
+                <a:cs typeface="Calibri" pitchFamily="34" charset="-120"/>
+              </a:rPr>
+              <a:t>10</a:t>
+            </a:r>
+            <a:endParaRPr lang="en-US" sz="1100" dirty="0"/>
+          </a:p>
+        </p:txBody>
+      </p:sp>
     </p:spTree>
   </p:cSld>
   <p:clrMapOvr>
@@ -3174,6 +3341,45 @@
           </a:p>
         </p:txBody>
       </p:sp>
+      <p:sp>
+        <p:nvSpPr>
+          <p:cNvPr id="18" name="Text 15"/>
+          <p:cNvSpPr/>
+          <p:nvPr/>
+        </p:nvSpPr>
+        <p:spPr>
+          <a:xfrm>
+            <a:off x="8229600" y="4809744"/>
+            <a:ext cx="658368" cy="274320"/>
+          </a:xfrm>
+          <a:prstGeom prst="rect">
+            <a:avLst/>
+          </a:prstGeom>
+          <a:noFill/>
+          <a:ln/>
+        </p:spPr>
+        <p:txBody>
+          <a:bodyPr wrap="square" lIns="0" tIns="0" rIns="0" bIns="0" rtlCol="0" anchor="ctr"/>
+          <a:lstStyle/>
+          <a:p>
+            <a:pPr algn="r" indent="0" marL="0">
+              <a:buNone/>
+            </a:pPr>
+            <a:r>
+              <a:rPr lang="en-US" sz="1100" dirty="0">
+                <a:solidFill>
+                  <a:srgbClr val="9AA5AD"/>
+                </a:solidFill>
+                <a:latin typeface="Calibri" pitchFamily="34" charset="0"/>
+                <a:ea typeface="Calibri" pitchFamily="34" charset="-122"/>
+                <a:cs typeface="Calibri" pitchFamily="34" charset="-120"/>
+              </a:rPr>
+              <a:t>11</a:t>
+            </a:r>
+            <a:endParaRPr lang="en-US" sz="1100" dirty="0"/>
+          </a:p>
+        </p:txBody>
+      </p:sp>
     </p:spTree>
   </p:cSld>
   <p:clrMapOvr>
@@ -3674,9 +3880,378 @@
                 <a:ea typeface="Calibri" pitchFamily="34" charset="-122"/>
                 <a:cs typeface="Calibri" pitchFamily="34" charset="-120"/>
               </a:rPr>
-              <a:t>instâncias maiores (n=2000), servidores heterogêneos e variantes do VMPACS com mais diversidade.</a:t>
+              <a:t>instâncias maiores (n=2000), servidores heterogêneos e versão memética do VMPACS (com busca local).</a:t>
             </a:r>
             <a:endParaRPr lang="en-US" sz="1350" dirty="0"/>
+          </a:p>
+        </p:txBody>
+      </p:sp>
+      <p:sp>
+        <p:nvSpPr>
+          <p:cNvPr id="17" name="Text 14"/>
+          <p:cNvSpPr/>
+          <p:nvPr/>
+        </p:nvSpPr>
+        <p:spPr>
+          <a:xfrm>
+            <a:off x="8229600" y="4809744"/>
+            <a:ext cx="658368" cy="274320"/>
+          </a:xfrm>
+          <a:prstGeom prst="rect">
+            <a:avLst/>
+          </a:prstGeom>
+          <a:noFill/>
+          <a:ln/>
+        </p:spPr>
+        <p:txBody>
+          <a:bodyPr wrap="square" lIns="0" tIns="0" rIns="0" bIns="0" rtlCol="0" anchor="ctr"/>
+          <a:lstStyle/>
+          <a:p>
+            <a:pPr algn="r" indent="0" marL="0">
+              <a:buNone/>
+            </a:pPr>
+            <a:r>
+              <a:rPr lang="en-US" sz="1100" dirty="0">
+                <a:solidFill>
+                  <a:srgbClr val="7E97A0"/>
+                </a:solidFill>
+                <a:latin typeface="Calibri" pitchFamily="34" charset="0"/>
+                <a:ea typeface="Calibri" pitchFamily="34" charset="-122"/>
+                <a:cs typeface="Calibri" pitchFamily="34" charset="-120"/>
+              </a:rPr>
+              <a:t>12</a:t>
+            </a:r>
+            <a:endParaRPr lang="en-US" sz="1100" dirty="0"/>
+          </a:p>
+        </p:txBody>
+      </p:sp>
+    </p:spTree>
+  </p:cSld>
+  <p:clrMapOvr>
+    <a:masterClrMapping/>
+  </p:clrMapOvr>
+</p:sld>
+</file>
+
+<file path=ppt/slides/slide13.xml><?xml version="1.0" encoding="utf-8"?>
+<p:sld xmlns:a="http://schemas.openxmlformats.org/drawingml/2006/main" xmlns:r="http://schemas.openxmlformats.org/officeDocument/2006/relationships" xmlns:p="http://schemas.openxmlformats.org/presentationml/2006/main">
+  <p:cSld name="Slide 13">
+    <p:bg>
+      <p:bgPr>
+        <a:solidFill>
+          <a:srgbClr val="15323B"/>
+        </a:solidFill>
+      </p:bgPr>
+    </p:bg>
+    <p:spTree>
+      <p:nvGrpSpPr>
+        <p:cNvPr id="1" name=""/>
+        <p:cNvGrpSpPr/>
+        <p:nvPr/>
+      </p:nvGrpSpPr>
+      <p:grpSpPr>
+        <a:xfrm>
+          <a:off x="0" y="0"/>
+          <a:ext cx="0" cy="0"/>
+          <a:chOff x="0" y="0"/>
+          <a:chExt cx="0" cy="0"/>
+        </a:xfrm>
+      </p:grpSpPr>
+      <p:sp>
+        <p:nvSpPr>
+          <p:cNvPr id="2" name="Shape 0"/>
+          <p:cNvSpPr/>
+          <p:nvPr/>
+        </p:nvSpPr>
+        <p:spPr>
+          <a:xfrm>
+            <a:off x="457200" y="365760"/>
+            <a:ext cx="502920" cy="502920"/>
+          </a:xfrm>
+          <a:prstGeom prst="ellipse">
+            <a:avLst/>
+          </a:prstGeom>
+          <a:solidFill>
+            <a:srgbClr val="0E7C86"/>
+          </a:solidFill>
+          <a:ln/>
+        </p:spPr>
+      </p:sp>
+      <p:sp>
+        <p:nvSpPr>
+          <p:cNvPr id="3" name="Text 1"/>
+          <p:cNvSpPr/>
+          <p:nvPr/>
+        </p:nvSpPr>
+        <p:spPr>
+          <a:xfrm>
+            <a:off x="457200" y="365760"/>
+            <a:ext cx="502920" cy="502920"/>
+          </a:xfrm>
+          <a:prstGeom prst="rect">
+            <a:avLst/>
+          </a:prstGeom>
+          <a:noFill/>
+          <a:ln/>
+        </p:spPr>
+        <p:txBody>
+          <a:bodyPr wrap="square" lIns="0" tIns="0" rIns="0" bIns="0" rtlCol="0" anchor="ctr"/>
+          <a:lstStyle/>
+          <a:p>
+            <a:pPr algn="ctr" indent="0" marL="0">
+              <a:buNone/>
+            </a:pPr>
+            <a:r>
+              <a:rPr lang="en-US" sz="1800" b="1" dirty="0">
+                <a:solidFill>
+                  <a:srgbClr val="FFFFFF"/>
+                </a:solidFill>
+                <a:latin typeface="Cambria" pitchFamily="34" charset="0"/>
+                <a:ea typeface="Cambria" pitchFamily="34" charset="-122"/>
+                <a:cs typeface="Cambria" pitchFamily="34" charset="-120"/>
+              </a:rPr>
+              <a:t>12</a:t>
+            </a:r>
+            <a:endParaRPr lang="en-US" sz="1800" dirty="0"/>
+          </a:p>
+        </p:txBody>
+      </p:sp>
+      <p:sp>
+        <p:nvSpPr>
+          <p:cNvPr id="4" name="Text 2"/>
+          <p:cNvSpPr/>
+          <p:nvPr/>
+        </p:nvSpPr>
+        <p:spPr>
+          <a:xfrm>
+            <a:off x="1097280" y="347472"/>
+            <a:ext cx="7315200" cy="548640"/>
+          </a:xfrm>
+          <a:prstGeom prst="rect">
+            <a:avLst/>
+          </a:prstGeom>
+          <a:noFill/>
+          <a:ln/>
+        </p:spPr>
+        <p:txBody>
+          <a:bodyPr wrap="square" lIns="0" tIns="0" rIns="0" bIns="0" rtlCol="0" anchor="ctr"/>
+          <a:lstStyle/>
+          <a:p>
+            <a:pPr indent="0" marL="0">
+              <a:buNone/>
+            </a:pPr>
+            <a:r>
+              <a:rPr lang="en-US" sz="2600" b="1" dirty="0">
+                <a:solidFill>
+                  <a:srgbClr val="FFFFFF"/>
+                </a:solidFill>
+                <a:latin typeface="Cambria" pitchFamily="34" charset="0"/>
+                <a:ea typeface="Cambria" pitchFamily="34" charset="-122"/>
+                <a:cs typeface="Cambria" pitchFamily="34" charset="-120"/>
+              </a:rPr>
+              <a:t>Referências</a:t>
+            </a:r>
+            <a:endParaRPr lang="en-US" sz="2600" dirty="0"/>
+          </a:p>
+        </p:txBody>
+      </p:sp>
+      <p:sp>
+        <p:nvSpPr>
+          <p:cNvPr id="5" name="Text 3"/>
+          <p:cNvSpPr/>
+          <p:nvPr/>
+        </p:nvSpPr>
+        <p:spPr>
+          <a:xfrm>
+            <a:off x="640080" y="1280160"/>
+            <a:ext cx="8046720" cy="3383280"/>
+          </a:xfrm>
+          <a:prstGeom prst="rect">
+            <a:avLst/>
+          </a:prstGeom>
+          <a:noFill/>
+          <a:ln/>
+        </p:spPr>
+        <p:txBody>
+          <a:bodyPr wrap="square" lIns="0" tIns="0" rIns="0" bIns="0" rtlCol="0" anchor="t"/>
+          <a:lstStyle/>
+          <a:p>
+            <a:pPr indent="0" marL="0">
+              <a:spcAft>
+                <a:spcPts val="1100"/>
+              </a:spcAft>
+              <a:buNone/>
+            </a:pPr>
+            <a:r>
+              <a:rPr lang="en-US" sz="1400" dirty="0">
+                <a:solidFill>
+                  <a:srgbClr val="E8EFF0"/>
+                </a:solidFill>
+                <a:latin typeface="Calibri" pitchFamily="34" charset="0"/>
+                <a:ea typeface="Calibri" pitchFamily="34" charset="-122"/>
+                <a:cs typeface="Calibri" pitchFamily="34" charset="-120"/>
+              </a:rPr>
+              <a:t>[1] Gao, Guan, Qi, Hou, Liu (2013). A multi-objective ant colony system algorithm for virtual machine placement in cloud computing. J. of Computer and System Sciences, 79(8), 1230-1242.</a:t>
+            </a:r>
+            <a:endParaRPr lang="en-US" sz="1400" dirty="0"/>
+          </a:p>
+          <a:p>
+            <a:pPr indent="0" marL="0">
+              <a:spcAft>
+                <a:spcPts val="1100"/>
+              </a:spcAft>
+              <a:buNone/>
+            </a:pPr>
+            <a:r>
+              <a:rPr lang="en-US" sz="1400" dirty="0">
+                <a:solidFill>
+                  <a:srgbClr val="E8EFF0"/>
+                </a:solidFill>
+                <a:latin typeface="Calibri" pitchFamily="34" charset="0"/>
+                <a:ea typeface="Calibri" pitchFamily="34" charset="-122"/>
+                <a:cs typeface="Calibri" pitchFamily="34" charset="-120"/>
+              </a:rPr>
+              <a:t>[2] Deb, Pratap, Agarwal, Meyarivan (2002). A fast and elitist multiobjective genetic algorithm: NSGA-II. IEEE Trans. on Evolutionary Computation, 6(2), 182-197.</a:t>
+            </a:r>
+            <a:endParaRPr lang="en-US" sz="1400" dirty="0"/>
+          </a:p>
+          <a:p>
+            <a:pPr indent="0" marL="0">
+              <a:spcAft>
+                <a:spcPts val="1100"/>
+              </a:spcAft>
+              <a:buNone/>
+            </a:pPr>
+            <a:r>
+              <a:rPr lang="en-US" sz="1400" dirty="0">
+                <a:solidFill>
+                  <a:srgbClr val="E8EFF0"/>
+                </a:solidFill>
+                <a:latin typeface="Calibri" pitchFamily="34" charset="0"/>
+                <a:ea typeface="Calibri" pitchFamily="34" charset="-122"/>
+                <a:cs typeface="Calibri" pitchFamily="34" charset="-120"/>
+              </a:rPr>
+              <a:t>[3] Dorigo, Gambardella (1997). Ant colony system: a cooperative learning approach to the TSP. IEEE Trans. on Evolutionary Computation, 1(1), 53-66.</a:t>
+            </a:r>
+            <a:endParaRPr lang="en-US" sz="1400" dirty="0"/>
+          </a:p>
+          <a:p>
+            <a:pPr indent="0" marL="0">
+              <a:spcAft>
+                <a:spcPts val="1100"/>
+              </a:spcAft>
+              <a:buNone/>
+            </a:pPr>
+            <a:r>
+              <a:rPr lang="en-US" sz="1400" dirty="0">
+                <a:solidFill>
+                  <a:srgbClr val="E8EFF0"/>
+                </a:solidFill>
+                <a:latin typeface="Calibri" pitchFamily="34" charset="0"/>
+                <a:ea typeface="Calibri" pitchFamily="34" charset="-122"/>
+                <a:cs typeface="Calibri" pitchFamily="34" charset="-120"/>
+              </a:rPr>
+              <a:t>[4] Zitzler, Thiele (1999). Multiobjective evolutionary algorithms: a comparative case study and the strength Pareto approach. IEEE Trans. on Evol. Computation, 3(4), 257-271.</a:t>
+            </a:r>
+            <a:endParaRPr lang="en-US" sz="1400" dirty="0"/>
+          </a:p>
+          <a:p>
+            <a:pPr indent="0" marL="0">
+              <a:spcAft>
+                <a:spcPts val="1100"/>
+              </a:spcAft>
+              <a:buNone/>
+            </a:pPr>
+            <a:r>
+              <a:rPr lang="en-US" sz="1400" dirty="0">
+                <a:solidFill>
+                  <a:srgbClr val="E8EFF0"/>
+                </a:solidFill>
+                <a:latin typeface="Calibri" pitchFamily="34" charset="0"/>
+                <a:ea typeface="Calibri" pitchFamily="34" charset="-122"/>
+                <a:cs typeface="Calibri" pitchFamily="34" charset="-120"/>
+              </a:rPr>
+              <a:t>[5] Van Veldhuizen (1999). Multiobjective Evolutionary Algorithms: Classifications, Analyses, and New Innovations. PhD thesis, Air Force Institute of Technology.</a:t>
+            </a:r>
+            <a:endParaRPr lang="en-US" sz="1400" dirty="0"/>
+          </a:p>
+        </p:txBody>
+      </p:sp>
+      <p:sp>
+        <p:nvSpPr>
+          <p:cNvPr id="6" name="Text 4"/>
+          <p:cNvSpPr/>
+          <p:nvPr/>
+        </p:nvSpPr>
+        <p:spPr>
+          <a:xfrm>
+            <a:off x="640080" y="4572000"/>
+            <a:ext cx="7863840" cy="365760"/>
+          </a:xfrm>
+          <a:prstGeom prst="rect">
+            <a:avLst/>
+          </a:prstGeom>
+          <a:noFill/>
+          <a:ln/>
+        </p:spPr>
+        <p:txBody>
+          <a:bodyPr wrap="square" lIns="0" tIns="0" rIns="0" bIns="0" rtlCol="0" anchor="ctr"/>
+          <a:lstStyle/>
+          <a:p>
+            <a:pPr indent="0" marL="0">
+              <a:buNone/>
+            </a:pPr>
+            <a:r>
+              <a:rPr lang="en-US" sz="1500" b="1" i="1" dirty="0">
+                <a:solidFill>
+                  <a:srgbClr val="0E7C86"/>
+                </a:solidFill>
+                <a:latin typeface="Cambria" pitchFamily="34" charset="0"/>
+                <a:ea typeface="Cambria" pitchFamily="34" charset="-122"/>
+                <a:cs typeface="Cambria" pitchFamily="34" charset="-120"/>
+              </a:rPr>
+              <a:t>Obrigado!  Perguntas?</a:t>
+            </a:r>
+            <a:endParaRPr lang="en-US" sz="1500" dirty="0"/>
+          </a:p>
+        </p:txBody>
+      </p:sp>
+      <p:sp>
+        <p:nvSpPr>
+          <p:cNvPr id="8" name="Text 5"/>
+          <p:cNvSpPr/>
+          <p:nvPr/>
+        </p:nvSpPr>
+        <p:spPr>
+          <a:xfrm>
+            <a:off x="8229600" y="4809744"/>
+            <a:ext cx="658368" cy="274320"/>
+          </a:xfrm>
+          <a:prstGeom prst="rect">
+            <a:avLst/>
+          </a:prstGeom>
+          <a:noFill/>
+          <a:ln/>
+        </p:spPr>
+        <p:txBody>
+          <a:bodyPr wrap="square" lIns="0" tIns="0" rIns="0" bIns="0" rtlCol="0" anchor="ctr"/>
+          <a:lstStyle/>
+          <a:p>
+            <a:pPr algn="r" indent="0" marL="0">
+              <a:buNone/>
+            </a:pPr>
+            <a:r>
+              <a:rPr lang="en-US" sz="1100" dirty="0">
+                <a:solidFill>
+                  <a:srgbClr val="7E97A0"/>
+                </a:solidFill>
+                <a:latin typeface="Calibri" pitchFamily="34" charset="0"/>
+                <a:ea typeface="Calibri" pitchFamily="34" charset="-122"/>
+                <a:cs typeface="Calibri" pitchFamily="34" charset="-120"/>
+              </a:rPr>
+              <a:t>13</a:t>
+            </a:r>
+            <a:endParaRPr lang="en-US" sz="1100" dirty="0"/>
           </a:p>
         </p:txBody>
       </p:sp>
@@ -4804,6 +5379,45 @@
           <a:ln/>
         </p:spPr>
       </p:sp>
+      <p:sp>
+        <p:nvSpPr>
+          <p:cNvPr id="43" name="Text 40"/>
+          <p:cNvSpPr/>
+          <p:nvPr/>
+        </p:nvSpPr>
+        <p:spPr>
+          <a:xfrm>
+            <a:off x="8229600" y="4809744"/>
+            <a:ext cx="658368" cy="274320"/>
+          </a:xfrm>
+          <a:prstGeom prst="rect">
+            <a:avLst/>
+          </a:prstGeom>
+          <a:noFill/>
+          <a:ln/>
+        </p:spPr>
+        <p:txBody>
+          <a:bodyPr wrap="square" lIns="0" tIns="0" rIns="0" bIns="0" rtlCol="0" anchor="ctr"/>
+          <a:lstStyle/>
+          <a:p>
+            <a:pPr algn="r" indent="0" marL="0">
+              <a:buNone/>
+            </a:pPr>
+            <a:r>
+              <a:rPr lang="en-US" sz="1100" dirty="0">
+                <a:solidFill>
+                  <a:srgbClr val="9AA5AD"/>
+                </a:solidFill>
+                <a:latin typeface="Calibri" pitchFamily="34" charset="0"/>
+                <a:ea typeface="Calibri" pitchFamily="34" charset="-122"/>
+                <a:cs typeface="Calibri" pitchFamily="34" charset="-120"/>
+              </a:rPr>
+              <a:t>2</a:t>
+            </a:r>
+            <a:endParaRPr lang="en-US" sz="1100" dirty="0"/>
+          </a:p>
+        </p:txBody>
+      </p:sp>
     </p:spTree>
   </p:cSld>
   <p:clrMapOvr>
@@ -5468,6 +6082,45 @@
           </a:p>
         </p:txBody>
       </p:sp>
+      <p:sp>
+        <p:nvSpPr>
+          <p:cNvPr id="18" name="Text 15"/>
+          <p:cNvSpPr/>
+          <p:nvPr/>
+        </p:nvSpPr>
+        <p:spPr>
+          <a:xfrm>
+            <a:off x="8229600" y="4809744"/>
+            <a:ext cx="658368" cy="274320"/>
+          </a:xfrm>
+          <a:prstGeom prst="rect">
+            <a:avLst/>
+          </a:prstGeom>
+          <a:noFill/>
+          <a:ln/>
+        </p:spPr>
+        <p:txBody>
+          <a:bodyPr wrap="square" lIns="0" tIns="0" rIns="0" bIns="0" rtlCol="0" anchor="ctr"/>
+          <a:lstStyle/>
+          <a:p>
+            <a:pPr algn="r" indent="0" marL="0">
+              <a:buNone/>
+            </a:pPr>
+            <a:r>
+              <a:rPr lang="en-US" sz="1100" dirty="0">
+                <a:solidFill>
+                  <a:srgbClr val="9AA5AD"/>
+                </a:solidFill>
+                <a:latin typeface="Calibri" pitchFamily="34" charset="0"/>
+                <a:ea typeface="Calibri" pitchFamily="34" charset="-122"/>
+                <a:cs typeface="Calibri" pitchFamily="34" charset="-120"/>
+              </a:rPr>
+              <a:t>3</a:t>
+            </a:r>
+            <a:endParaRPr lang="en-US" sz="1100" dirty="0"/>
+          </a:p>
+        </p:txBody>
+      </p:sp>
     </p:spTree>
   </p:cSld>
   <p:clrMapOvr>
@@ -5787,6 +6440,45 @@
           </a:p>
         </p:txBody>
       </p:sp>
+      <p:sp>
+        <p:nvSpPr>
+          <p:cNvPr id="9" name="Text 5"/>
+          <p:cNvSpPr/>
+          <p:nvPr/>
+        </p:nvSpPr>
+        <p:spPr>
+          <a:xfrm>
+            <a:off x="8229600" y="4809744"/>
+            <a:ext cx="658368" cy="274320"/>
+          </a:xfrm>
+          <a:prstGeom prst="rect">
+            <a:avLst/>
+          </a:prstGeom>
+          <a:noFill/>
+          <a:ln/>
+        </p:spPr>
+        <p:txBody>
+          <a:bodyPr wrap="square" lIns="0" tIns="0" rIns="0" bIns="0" rtlCol="0" anchor="ctr"/>
+          <a:lstStyle/>
+          <a:p>
+            <a:pPr algn="r" indent="0" marL="0">
+              <a:buNone/>
+            </a:pPr>
+            <a:r>
+              <a:rPr lang="en-US" sz="1100" dirty="0">
+                <a:solidFill>
+                  <a:srgbClr val="9AA5AD"/>
+                </a:solidFill>
+                <a:latin typeface="Calibri" pitchFamily="34" charset="0"/>
+                <a:ea typeface="Calibri" pitchFamily="34" charset="-122"/>
+                <a:cs typeface="Calibri" pitchFamily="34" charset="-120"/>
+              </a:rPr>
+              <a:t>4</a:t>
+            </a:r>
+            <a:endParaRPr lang="en-US" sz="1100" dirty="0"/>
+          </a:p>
+        </p:txBody>
+      </p:sp>
     </p:spTree>
   </p:cSld>
   <p:clrMapOvr>
@@ -6433,6 +7125,45 @@
           </a:p>
         </p:txBody>
       </p:sp>
+      <p:sp>
+        <p:nvSpPr>
+          <p:cNvPr id="22" name="Text 19"/>
+          <p:cNvSpPr/>
+          <p:nvPr/>
+        </p:nvSpPr>
+        <p:spPr>
+          <a:xfrm>
+            <a:off x="8229600" y="4809744"/>
+            <a:ext cx="658368" cy="274320"/>
+          </a:xfrm>
+          <a:prstGeom prst="rect">
+            <a:avLst/>
+          </a:prstGeom>
+          <a:noFill/>
+          <a:ln/>
+        </p:spPr>
+        <p:txBody>
+          <a:bodyPr wrap="square" lIns="0" tIns="0" rIns="0" bIns="0" rtlCol="0" anchor="ctr"/>
+          <a:lstStyle/>
+          <a:p>
+            <a:pPr algn="r" indent="0" marL="0">
+              <a:buNone/>
+            </a:pPr>
+            <a:r>
+              <a:rPr lang="en-US" sz="1100" dirty="0">
+                <a:solidFill>
+                  <a:srgbClr val="7E97A0"/>
+                </a:solidFill>
+                <a:latin typeface="Calibri" pitchFamily="34" charset="0"/>
+                <a:ea typeface="Calibri" pitchFamily="34" charset="-122"/>
+                <a:cs typeface="Calibri" pitchFamily="34" charset="-120"/>
+              </a:rPr>
+              <a:t>5</a:t>
+            </a:r>
+            <a:endParaRPr lang="en-US" sz="1100" dirty="0"/>
+          </a:p>
+        </p:txBody>
+      </p:sp>
     </p:spTree>
   </p:cSld>
   <p:clrMapOvr>
@@ -7361,6 +8092,45 @@
           </a:p>
         </p:txBody>
       </p:sp>
+      <p:sp>
+        <p:nvSpPr>
+          <p:cNvPr id="25" name="Text 22"/>
+          <p:cNvSpPr/>
+          <p:nvPr/>
+        </p:nvSpPr>
+        <p:spPr>
+          <a:xfrm>
+            <a:off x="8229600" y="4809744"/>
+            <a:ext cx="658368" cy="274320"/>
+          </a:xfrm>
+          <a:prstGeom prst="rect">
+            <a:avLst/>
+          </a:prstGeom>
+          <a:noFill/>
+          <a:ln/>
+        </p:spPr>
+        <p:txBody>
+          <a:bodyPr wrap="square" lIns="0" tIns="0" rIns="0" bIns="0" rtlCol="0" anchor="ctr"/>
+          <a:lstStyle/>
+          <a:p>
+            <a:pPr algn="r" indent="0" marL="0">
+              <a:buNone/>
+            </a:pPr>
+            <a:r>
+              <a:rPr lang="en-US" sz="1100" dirty="0">
+                <a:solidFill>
+                  <a:srgbClr val="9AA5AD"/>
+                </a:solidFill>
+                <a:latin typeface="Calibri" pitchFamily="34" charset="0"/>
+                <a:ea typeface="Calibri" pitchFamily="34" charset="-122"/>
+                <a:cs typeface="Calibri" pitchFamily="34" charset="-120"/>
+              </a:rPr>
+              <a:t>6</a:t>
+            </a:r>
+            <a:endParaRPr lang="en-US" sz="1100" dirty="0"/>
+          </a:p>
+        </p:txBody>
+      </p:sp>
     </p:spTree>
   </p:cSld>
   <p:clrMapOvr>
@@ -7972,6 +8742,45 @@
           </a:p>
         </p:txBody>
       </p:sp>
+      <p:sp>
+        <p:nvSpPr>
+          <p:cNvPr id="19" name="Text 16"/>
+          <p:cNvSpPr/>
+          <p:nvPr/>
+        </p:nvSpPr>
+        <p:spPr>
+          <a:xfrm>
+            <a:off x="8229600" y="4809744"/>
+            <a:ext cx="658368" cy="274320"/>
+          </a:xfrm>
+          <a:prstGeom prst="rect">
+            <a:avLst/>
+          </a:prstGeom>
+          <a:noFill/>
+          <a:ln/>
+        </p:spPr>
+        <p:txBody>
+          <a:bodyPr wrap="square" lIns="0" tIns="0" rIns="0" bIns="0" rtlCol="0" anchor="ctr"/>
+          <a:lstStyle/>
+          <a:p>
+            <a:pPr algn="r" indent="0" marL="0">
+              <a:buNone/>
+            </a:pPr>
+            <a:r>
+              <a:rPr lang="en-US" sz="1100" dirty="0">
+                <a:solidFill>
+                  <a:srgbClr val="9AA5AD"/>
+                </a:solidFill>
+                <a:latin typeface="Calibri" pitchFamily="34" charset="0"/>
+                <a:ea typeface="Calibri" pitchFamily="34" charset="-122"/>
+                <a:cs typeface="Calibri" pitchFamily="34" charset="-120"/>
+              </a:rPr>
+              <a:t>7</a:t>
+            </a:r>
+            <a:endParaRPr lang="en-US" sz="1100" dirty="0"/>
+          </a:p>
+        </p:txBody>
+      </p:sp>
     </p:spTree>
   </p:cSld>
   <p:clrMapOvr>
@@ -8766,6 +9575,45 @@
           </a:p>
         </p:txBody>
       </p:sp>
+      <p:sp>
+        <p:nvSpPr>
+          <p:cNvPr id="26" name="Text 23"/>
+          <p:cNvSpPr/>
+          <p:nvPr/>
+        </p:nvSpPr>
+        <p:spPr>
+          <a:xfrm>
+            <a:off x="8229600" y="4809744"/>
+            <a:ext cx="658368" cy="274320"/>
+          </a:xfrm>
+          <a:prstGeom prst="rect">
+            <a:avLst/>
+          </a:prstGeom>
+          <a:noFill/>
+          <a:ln/>
+        </p:spPr>
+        <p:txBody>
+          <a:bodyPr wrap="square" lIns="0" tIns="0" rIns="0" bIns="0" rtlCol="0" anchor="ctr"/>
+          <a:lstStyle/>
+          <a:p>
+            <a:pPr algn="r" indent="0" marL="0">
+              <a:buNone/>
+            </a:pPr>
+            <a:r>
+              <a:rPr lang="en-US" sz="1100" dirty="0">
+                <a:solidFill>
+                  <a:srgbClr val="9AA5AD"/>
+                </a:solidFill>
+                <a:latin typeface="Calibri" pitchFamily="34" charset="0"/>
+                <a:ea typeface="Calibri" pitchFamily="34" charset="-122"/>
+                <a:cs typeface="Calibri" pitchFamily="34" charset="-120"/>
+              </a:rPr>
+              <a:t>8</a:t>
+            </a:r>
+            <a:endParaRPr lang="en-US" sz="1100" dirty="0"/>
+          </a:p>
+        </p:txBody>
+      </p:sp>
     </p:spTree>
   </p:cSld>
   <p:clrMapOvr>
@@ -9021,6 +9869,45 @@
               <a:t>o NSGA-II atinge menor energia em 4 de 5 cenários e menor desperdício em 4 de 5 (exceção em P=0.5).</a:t>
             </a:r>
             <a:endParaRPr lang="en-US" sz="1400" dirty="0"/>
+          </a:p>
+        </p:txBody>
+      </p:sp>
+      <p:sp>
+        <p:nvSpPr>
+          <p:cNvPr id="10" name="Text 5"/>
+          <p:cNvSpPr/>
+          <p:nvPr/>
+        </p:nvSpPr>
+        <p:spPr>
+          <a:xfrm>
+            <a:off x="8229600" y="4809744"/>
+            <a:ext cx="658368" cy="274320"/>
+          </a:xfrm>
+          <a:prstGeom prst="rect">
+            <a:avLst/>
+          </a:prstGeom>
+          <a:noFill/>
+          <a:ln/>
+        </p:spPr>
+        <p:txBody>
+          <a:bodyPr wrap="square" lIns="0" tIns="0" rIns="0" bIns="0" rtlCol="0" anchor="ctr"/>
+          <a:lstStyle/>
+          <a:p>
+            <a:pPr algn="r" indent="0" marL="0">
+              <a:buNone/>
+            </a:pPr>
+            <a:r>
+              <a:rPr lang="en-US" sz="1100" dirty="0">
+                <a:solidFill>
+                  <a:srgbClr val="9AA5AD"/>
+                </a:solidFill>
+                <a:latin typeface="Calibri" pitchFamily="34" charset="0"/>
+                <a:ea typeface="Calibri" pitchFamily="34" charset="-122"/>
+                <a:cs typeface="Calibri" pitchFamily="34" charset="-120"/>
+              </a:rPr>
+              <a:t>9</a:t>
+            </a:r>
+            <a:endParaRPr lang="en-US" sz="1100" dirty="0"/>
           </a:p>
         </p:txBody>
       </p:sp>

</xml_diff>